<commit_message>
Add bge-small benchmark result, resumable embedding cache, deck and README updates
- CachedEmbedder saves embeddings in slices so a stopped run resumes
- configs/default.json uses bge-small, the model behind the submitted result
- run_summary.json from the full CoIR apps run (NDCG@10 0.06698, MRR@10 0.057086)
- README results block and deck show exact values; weights stated as set by hand, not tuned
- demo_output.txt from the real model
- AI disclosure and deck name BAAI/bge-small-en-v1.5
</commit_message>
<xml_diff>
--- a/submission/VITV_TeamName_Submission.pptx
+++ b/submission/VITV_TeamName_Submission.pptx
@@ -13576,7 +13576,7 @@
                 <a:cs typeface="Calibri"/>
                 <a:sym typeface="Calibri"/>
               </a:rPr>
-              <a:t>Submission Github link - [GitHub repo URL]</a:t>
+              <a:t>Submission Github link - https://github.com/pj4real/prism-code-retrieval</a:t>
             </a:r>
             <a:endParaRPr/>
           </a:p>
@@ -14361,7 +14361,7 @@
                 </a:solidFill>
                 <a:latin typeface="Calibri"/>
               </a:rPr>
-              <a:t>We say when weights were tuned on the test split, and how we worked around the to_dict bug in MTEB 2.21.9.</a:t>
+              <a:t>We say the fusion weights were set by hand and not tuned, and how we worked around the to_dict bug in MTEB 2.21.9.</a:t>
             </a:r>
           </a:p>
         </p:txBody>
@@ -14949,7 +14949,7 @@
                 </a:solidFill>
                 <a:latin typeface="Calibri"/>
               </a:rPr>
-              <a:t>[GitHub repo URL]</a:t>
+              <a:t>https://github.com/pj4real/prism-code-retrieval</a:t>
             </a:r>
           </a:p>
         </p:txBody>
@@ -15996,7 +15996,7 @@
                 </a:solidFill>
                 <a:latin typeface="Calibri"/>
               </a:rPr>
-              <a:t>Code: [GitHub repo URL]</a:t>
+              <a:t>Code: https://github.com/pj4real/prism-code-retrieval</a:t>
             </a:r>
           </a:p>
         </p:txBody>
@@ -18386,7 +18386,7 @@
                 </a:solidFill>
                 <a:latin typeface="Calibri"/>
               </a:rPr>
-              <a:t>gte-modernbert-base</a:t>
+              <a:t>bge-small-en-v1.5</a:t>
             </a:r>
           </a:p>
           <a:p>
@@ -20179,7 +20179,7 @@
                 </a:solidFill>
                 <a:latin typeface="Calibri"/>
               </a:rPr>
-              <a:t>Alibaba-NLP/gte-modernbert-base, pretrained, not fine tuned</a:t>
+              <a:t>BAAI/bge-small-en-v1.5, pretrained, not fine tuned</a:t>
             </a:r>
           </a:p>
           <a:p>
@@ -21938,13 +21938,13 @@
           <a:p>
             <a:pPr algn="l"/>
             <a:r>
-              <a:rPr sz="2400" b="1" i="0">
-                <a:solidFill>
-                  <a:srgbClr val="C26A00"/>
+              <a:rPr sz="4400" b="1" i="0">
+                <a:solidFill>
+                  <a:srgbClr val="704EA6"/>
                 </a:solidFill>
                 <a:latin typeface="Calibri"/>
               </a:rPr>
-              <a:t>pending</a:t>
+              <a:t>0.06698</a:t>
             </a:r>
           </a:p>
         </p:txBody>
@@ -22008,13 +22008,13 @@
           <a:p>
             <a:pPr algn="l"/>
             <a:r>
-              <a:rPr sz="2400" b="1" i="0">
-                <a:solidFill>
-                  <a:srgbClr val="C26A00"/>
+              <a:rPr sz="4400" b="1" i="0">
+                <a:solidFill>
+                  <a:srgbClr val="704EA6"/>
                 </a:solidFill>
                 <a:latin typeface="Calibri"/>
               </a:rPr>
-              <a:t>pending</a:t>
+              <a:t>0.057086</a:t>
             </a:r>
           </a:p>
         </p:txBody>
@@ -22049,7 +22049,7 @@
                 </a:solidFill>
                 <a:latin typeface="Calibri"/>
               </a:rPr>
-              <a:t>Full run on CoIR apps test split not finished when this deck was built.</a:t>
+              <a:t>CoIR apps test split, full corpus: 8,765 documents, 3,765 queries. Whole run 359.3 s on 10 CPU cores.</a:t>
             </a:r>
           </a:p>
         </p:txBody>
@@ -22183,7 +22183,7 @@
                 </a:solidFill>
                 <a:latin typeface="Calibri"/>
               </a:rPr>
-              <a:t>• Weights were tuned on a sample of the test split. Read the score with that in mind.</a:t>
+              <a:t>• Fusion weights were set by hand and not tuned.</a:t>
             </a:r>
           </a:p>
         </p:txBody>
@@ -22457,7 +22457,7 @@
                 </a:solidFill>
                 <a:latin typeface="Calibri"/>
               </a:rPr>
-              <a:t>• Tune weights on a held out split instead of a test sample.</a:t>
+              <a:t>• Tune the fusion weights on a held out split. They are set by hand today.</a:t>
             </a:r>
           </a:p>
           <a:p>

</xml_diff>